<commit_message>
Product Variant- Create necessary files
</commit_message>
<xml_diff>
--- a/.lessons/58 Backend Product And Related Features/17 Product- Working with image gallery (part - 2)/1.pptx
+++ b/.lessons/58 Backend Product And Related Features/17 Product- Working with image gallery (part - 2)/1.pptx
@@ -7,7 +7,13 @@
   <p:sldIdLst>
     <p:sldId id="413" r:id="rId2"/>
     <p:sldId id="414" r:id="rId3"/>
-    <p:sldId id="400" r:id="rId4"/>
+    <p:sldId id="415" r:id="rId4"/>
+    <p:sldId id="417" r:id="rId5"/>
+    <p:sldId id="416" r:id="rId6"/>
+    <p:sldId id="418" r:id="rId7"/>
+    <p:sldId id="419" r:id="rId8"/>
+    <p:sldId id="420" r:id="rId9"/>
+    <p:sldId id="400" r:id="rId10"/>
   </p:sldIdLst>
   <p:sldSz cx="12192000" cy="6858000"/>
   <p:notesSz cx="6858000" cy="9144000"/>
@@ -261,7 +267,7 @@
           <a:p>
             <a:fld id="{3E102D2E-813C-461C-9963-687A650C48C0}" type="datetimeFigureOut">
               <a:rPr lang="en-US" smtClean="0"/>
-              <a:t>6/26/2025</a:t>
+              <a:t>10/8/2025</a:t>
             </a:fld>
             <a:endParaRPr lang="en-US"/>
           </a:p>
@@ -459,7 +465,7 @@
           <a:p>
             <a:fld id="{3E102D2E-813C-461C-9963-687A650C48C0}" type="datetimeFigureOut">
               <a:rPr lang="en-US" smtClean="0"/>
-              <a:t>6/26/2025</a:t>
+              <a:t>10/8/2025</a:t>
             </a:fld>
             <a:endParaRPr lang="en-US"/>
           </a:p>
@@ -667,7 +673,7 @@
           <a:p>
             <a:fld id="{3E102D2E-813C-461C-9963-687A650C48C0}" type="datetimeFigureOut">
               <a:rPr lang="en-US" smtClean="0"/>
-              <a:t>6/26/2025</a:t>
+              <a:t>10/8/2025</a:t>
             </a:fld>
             <a:endParaRPr lang="en-US"/>
           </a:p>
@@ -865,7 +871,7 @@
           <a:p>
             <a:fld id="{3E102D2E-813C-461C-9963-687A650C48C0}" type="datetimeFigureOut">
               <a:rPr lang="en-US" smtClean="0"/>
-              <a:t>6/26/2025</a:t>
+              <a:t>10/8/2025</a:t>
             </a:fld>
             <a:endParaRPr lang="en-US"/>
           </a:p>
@@ -1140,7 +1146,7 @@
           <a:p>
             <a:fld id="{3E102D2E-813C-461C-9963-687A650C48C0}" type="datetimeFigureOut">
               <a:rPr lang="en-US" smtClean="0"/>
-              <a:t>6/26/2025</a:t>
+              <a:t>10/8/2025</a:t>
             </a:fld>
             <a:endParaRPr lang="en-US"/>
           </a:p>
@@ -1405,7 +1411,7 @@
           <a:p>
             <a:fld id="{3E102D2E-813C-461C-9963-687A650C48C0}" type="datetimeFigureOut">
               <a:rPr lang="en-US" smtClean="0"/>
-              <a:t>6/26/2025</a:t>
+              <a:t>10/8/2025</a:t>
             </a:fld>
             <a:endParaRPr lang="en-US"/>
           </a:p>
@@ -1817,7 +1823,7 @@
           <a:p>
             <a:fld id="{3E102D2E-813C-461C-9963-687A650C48C0}" type="datetimeFigureOut">
               <a:rPr lang="en-US" smtClean="0"/>
-              <a:t>6/26/2025</a:t>
+              <a:t>10/8/2025</a:t>
             </a:fld>
             <a:endParaRPr lang="en-US"/>
           </a:p>
@@ -1958,7 +1964,7 @@
           <a:p>
             <a:fld id="{3E102D2E-813C-461C-9963-687A650C48C0}" type="datetimeFigureOut">
               <a:rPr lang="en-US" smtClean="0"/>
-              <a:t>6/26/2025</a:t>
+              <a:t>10/8/2025</a:t>
             </a:fld>
             <a:endParaRPr lang="en-US"/>
           </a:p>
@@ -2071,7 +2077,7 @@
           <a:p>
             <a:fld id="{3E102D2E-813C-461C-9963-687A650C48C0}" type="datetimeFigureOut">
               <a:rPr lang="en-US" smtClean="0"/>
-              <a:t>6/26/2025</a:t>
+              <a:t>10/8/2025</a:t>
             </a:fld>
             <a:endParaRPr lang="en-US"/>
           </a:p>
@@ -2382,7 +2388,7 @@
           <a:p>
             <a:fld id="{3E102D2E-813C-461C-9963-687A650C48C0}" type="datetimeFigureOut">
               <a:rPr lang="en-US" smtClean="0"/>
-              <a:t>6/26/2025</a:t>
+              <a:t>10/8/2025</a:t>
             </a:fld>
             <a:endParaRPr lang="en-US"/>
           </a:p>
@@ -2670,7 +2676,7 @@
           <a:p>
             <a:fld id="{3E102D2E-813C-461C-9963-687A650C48C0}" type="datetimeFigureOut">
               <a:rPr lang="en-US" smtClean="0"/>
-              <a:t>6/26/2025</a:t>
+              <a:t>10/8/2025</a:t>
             </a:fld>
             <a:endParaRPr lang="en-US"/>
           </a:p>
@@ -2911,7 +2917,7 @@
           <a:p>
             <a:fld id="{3E102D2E-813C-461C-9963-687A650C48C0}" type="datetimeFigureOut">
               <a:rPr lang="en-US" smtClean="0"/>
-              <a:t>6/26/2025</a:t>
+              <a:t>10/8/2025</a:t>
             </a:fld>
             <a:endParaRPr lang="en-US"/>
           </a:p>
@@ -3369,21 +3375,66 @@
               <a:buNone/>
             </a:pPr>
             <a:r>
-              <a:rPr kumimoji="0" lang="en-US" altLang="en-US" sz="1300" b="0" i="0" u="none" strike="noStrike" cap="none" normalizeH="0" baseline="0">
-                <a:ln>
-                  <a:noFill/>
-                </a:ln>
-                <a:solidFill>
-                  <a:schemeClr val="tx1"/>
-                </a:solidFill>
-                <a:effectLst/>
+              <a:rPr lang="en-US" altLang="en-US" sz="1300">
                 <a:latin typeface="Arial" panose="020B0604020202020204" pitchFamily="34" charset="0"/>
               </a:rPr>
-              <a:t>.</a:t>
-            </a:r>
-          </a:p>
-        </p:txBody>
-      </p:sp>
+              <a:t>database\migrations\2025_10_07_145747_create_</a:t>
+            </a:r>
+            <a:r>
+              <a:rPr lang="en-US" altLang="en-US" sz="1300" b="1">
+                <a:latin typeface="Arial" panose="020B0604020202020204" pitchFamily="34" charset="0"/>
+              </a:rPr>
+              <a:t>product_image_galleries</a:t>
+            </a:r>
+            <a:r>
+              <a:rPr lang="en-US" altLang="en-US" sz="1300">
+                <a:latin typeface="Arial" panose="020B0604020202020204" pitchFamily="34" charset="0"/>
+              </a:rPr>
+              <a:t>_table.php</a:t>
+            </a:r>
+            <a:endParaRPr kumimoji="0" lang="en-US" altLang="en-US" sz="1300" b="0" i="0" u="none" strike="noStrike" cap="none" normalizeH="0" baseline="0">
+              <a:ln>
+                <a:noFill/>
+              </a:ln>
+              <a:solidFill>
+                <a:schemeClr val="tx1"/>
+              </a:solidFill>
+              <a:effectLst/>
+              <a:latin typeface="Arial" panose="020B0604020202020204" pitchFamily="34" charset="0"/>
+            </a:endParaRPr>
+          </a:p>
+        </p:txBody>
+      </p:sp>
+      <p:pic>
+        <p:nvPicPr>
+          <p:cNvPr id="4" name="Picture 3">
+            <a:extLst>
+              <a:ext uri="{FF2B5EF4-FFF2-40B4-BE49-F238E27FC236}">
+                <a16:creationId xmlns:a16="http://schemas.microsoft.com/office/drawing/2014/main" id="{119E98E1-109A-9D07-A8F9-93D6F6CD225B}"/>
+              </a:ext>
+            </a:extLst>
+          </p:cNvPr>
+          <p:cNvPicPr>
+            <a:picLocks noChangeAspect="1"/>
+          </p:cNvPicPr>
+          <p:nvPr/>
+        </p:nvPicPr>
+        <p:blipFill>
+          <a:blip r:embed="rId2"/>
+          <a:stretch>
+            <a:fillRect/>
+          </a:stretch>
+        </p:blipFill>
+        <p:spPr>
+          <a:xfrm>
+            <a:off x="5763490" y="1131914"/>
+            <a:ext cx="6428509" cy="5726085"/>
+          </a:xfrm>
+          <a:prstGeom prst="rect">
+            <a:avLst/>
+          </a:prstGeom>
+        </p:spPr>
+      </p:pic>
     </p:spTree>
     <p:extLst>
       <p:ext uri="{BB962C8B-B14F-4D97-AF65-F5344CB8AC3E}">
@@ -3470,6 +3521,36 @@
           </a:p>
         </p:txBody>
       </p:sp>
+      <p:pic>
+        <p:nvPicPr>
+          <p:cNvPr id="4" name="Picture 3">
+            <a:extLst>
+              <a:ext uri="{FF2B5EF4-FFF2-40B4-BE49-F238E27FC236}">
+                <a16:creationId xmlns:a16="http://schemas.microsoft.com/office/drawing/2014/main" id="{5EB80301-57D1-DA12-62B3-721DC6F075C4}"/>
+              </a:ext>
+            </a:extLst>
+          </p:cNvPr>
+          <p:cNvPicPr>
+            <a:picLocks noChangeAspect="1"/>
+          </p:cNvPicPr>
+          <p:nvPr/>
+        </p:nvPicPr>
+        <p:blipFill>
+          <a:blip r:embed="rId2"/>
+          <a:stretch>
+            <a:fillRect/>
+          </a:stretch>
+        </p:blipFill>
+        <p:spPr>
+          <a:xfrm>
+            <a:off x="970834" y="2547814"/>
+            <a:ext cx="10250330" cy="1762371"/>
+          </a:xfrm>
+          <a:prstGeom prst="rect">
+            <a:avLst/>
+          </a:prstGeom>
+        </p:spPr>
+      </p:pic>
     </p:spTree>
     <p:extLst>
       <p:ext uri="{BB962C8B-B14F-4D97-AF65-F5344CB8AC3E}">
@@ -3484,6 +3565,693 @@
 </file>
 
 <file path=ppt/slides/slide3.xml><?xml version="1.0" encoding="utf-8"?>
+<p:sld xmlns:a="http://schemas.openxmlformats.org/drawingml/2006/main" xmlns:r="http://schemas.openxmlformats.org/officeDocument/2006/relationships" xmlns:p="http://schemas.openxmlformats.org/presentationml/2006/main">
+  <p:cSld>
+    <p:spTree>
+      <p:nvGrpSpPr>
+        <p:cNvPr id="1" name="">
+          <a:extLst>
+            <a:ext uri="{FF2B5EF4-FFF2-40B4-BE49-F238E27FC236}">
+              <a16:creationId xmlns:a16="http://schemas.microsoft.com/office/drawing/2014/main" id="{670050D3-4F8E-B75F-6983-F09958E0FCE4}"/>
+            </a:ext>
+          </a:extLst>
+        </p:cNvPr>
+        <p:cNvGrpSpPr/>
+        <p:nvPr/>
+      </p:nvGrpSpPr>
+      <p:grpSpPr>
+        <a:xfrm>
+          <a:off x="0" y="0"/>
+          <a:ext cx="0" cy="0"/>
+          <a:chOff x="0" y="0"/>
+          <a:chExt cx="0" cy="0"/>
+        </a:xfrm>
+      </p:grpSpPr>
+      <p:sp>
+        <p:nvSpPr>
+          <p:cNvPr id="3" name="TextBox 2">
+            <a:extLst>
+              <a:ext uri="{FF2B5EF4-FFF2-40B4-BE49-F238E27FC236}">
+                <a16:creationId xmlns:a16="http://schemas.microsoft.com/office/drawing/2014/main" id="{E8414C3C-857E-B160-FD05-DFE1FBC4BC22}"/>
+              </a:ext>
+            </a:extLst>
+          </p:cNvPr>
+          <p:cNvSpPr txBox="1"/>
+          <p:nvPr/>
+        </p:nvSpPr>
+        <p:spPr>
+          <a:xfrm>
+            <a:off x="217714" y="255046"/>
+            <a:ext cx="11756571" cy="655436"/>
+          </a:xfrm>
+          <a:prstGeom prst="rect">
+            <a:avLst/>
+          </a:prstGeom>
+          <a:noFill/>
+        </p:spPr>
+        <p:txBody>
+          <a:bodyPr wrap="square">
+            <a:spAutoFit/>
+          </a:bodyPr>
+          <a:lstStyle/>
+          <a:p>
+            <a:pPr>
+              <a:lnSpc>
+                <a:spcPct val="150000"/>
+              </a:lnSpc>
+              <a:buNone/>
+            </a:pPr>
+            <a:r>
+              <a:rPr lang="az-Latn-AZ" altLang="en-US" sz="1300">
+                <a:latin typeface="Arial" panose="020B0604020202020204" pitchFamily="34" charset="0"/>
+              </a:rPr>
+              <a:t>Çoxlu şəkillər əlavə edəcəyimiz üçün, </a:t>
+            </a:r>
+            <a:r>
+              <a:rPr lang="az-Latn-AZ" altLang="en-US" sz="1300" b="1">
+                <a:latin typeface="Arial" panose="020B0604020202020204" pitchFamily="34" charset="0"/>
+              </a:rPr>
+              <a:t>uploadMultiİmage() </a:t>
+            </a:r>
+            <a:r>
+              <a:rPr lang="az-Latn-AZ" altLang="en-US" sz="1300">
+                <a:latin typeface="Arial" panose="020B0604020202020204" pitchFamily="34" charset="0"/>
+              </a:rPr>
+              <a:t>adında</a:t>
+            </a:r>
+          </a:p>
+          <a:p>
+            <a:pPr>
+              <a:lnSpc>
+                <a:spcPct val="150000"/>
+              </a:lnSpc>
+              <a:buNone/>
+            </a:pPr>
+            <a:r>
+              <a:rPr lang="az-Latn-AZ" altLang="en-US" sz="1300">
+                <a:latin typeface="Arial" panose="020B0604020202020204" pitchFamily="34" charset="0"/>
+              </a:rPr>
+              <a:t>metod əlavə edirik </a:t>
+            </a:r>
+            <a:r>
+              <a:rPr lang="az-Latn-AZ" altLang="en-US" sz="1300" b="1">
+                <a:latin typeface="Arial" panose="020B0604020202020204" pitchFamily="34" charset="0"/>
+              </a:rPr>
+              <a:t>Trait</a:t>
+            </a:r>
+            <a:r>
+              <a:rPr lang="az-Latn-AZ" altLang="en-US" sz="1300">
+                <a:latin typeface="Arial" panose="020B0604020202020204" pitchFamily="34" charset="0"/>
+              </a:rPr>
+              <a:t> -imizin içinə.</a:t>
+            </a:r>
+            <a:endParaRPr kumimoji="0" lang="en-US" altLang="en-US" sz="1300" b="0" i="0" u="none" strike="noStrike" cap="none" normalizeH="0" baseline="0">
+              <a:ln>
+                <a:noFill/>
+              </a:ln>
+              <a:solidFill>
+                <a:schemeClr val="tx1"/>
+              </a:solidFill>
+              <a:effectLst/>
+              <a:latin typeface="Arial" panose="020B0604020202020204" pitchFamily="34" charset="0"/>
+            </a:endParaRPr>
+          </a:p>
+        </p:txBody>
+      </p:sp>
+      <p:pic>
+        <p:nvPicPr>
+          <p:cNvPr id="4" name="Picture 3">
+            <a:extLst>
+              <a:ext uri="{FF2B5EF4-FFF2-40B4-BE49-F238E27FC236}">
+                <a16:creationId xmlns:a16="http://schemas.microsoft.com/office/drawing/2014/main" id="{0FED2841-9684-3F34-57E7-7636F886CE98}"/>
+              </a:ext>
+            </a:extLst>
+          </p:cNvPr>
+          <p:cNvPicPr>
+            <a:picLocks noChangeAspect="1"/>
+          </p:cNvPicPr>
+          <p:nvPr/>
+        </p:nvPicPr>
+        <p:blipFill>
+          <a:blip r:embed="rId2"/>
+          <a:stretch>
+            <a:fillRect/>
+          </a:stretch>
+        </p:blipFill>
+        <p:spPr>
+          <a:xfrm>
+            <a:off x="6029392" y="0"/>
+            <a:ext cx="6162608" cy="6858000"/>
+          </a:xfrm>
+          <a:prstGeom prst="rect">
+            <a:avLst/>
+          </a:prstGeom>
+        </p:spPr>
+      </p:pic>
+    </p:spTree>
+    <p:extLst>
+      <p:ext uri="{BB962C8B-B14F-4D97-AF65-F5344CB8AC3E}">
+        <p14:creationId xmlns:p14="http://schemas.microsoft.com/office/powerpoint/2010/main" val="605431902"/>
+      </p:ext>
+    </p:extLst>
+  </p:cSld>
+  <p:clrMapOvr>
+    <a:masterClrMapping/>
+  </p:clrMapOvr>
+</p:sld>
+</file>
+
+<file path=ppt/slides/slide4.xml><?xml version="1.0" encoding="utf-8"?>
+<p:sld xmlns:a="http://schemas.openxmlformats.org/drawingml/2006/main" xmlns:r="http://schemas.openxmlformats.org/officeDocument/2006/relationships" xmlns:p="http://schemas.openxmlformats.org/presentationml/2006/main">
+  <p:cSld>
+    <p:spTree>
+      <p:nvGrpSpPr>
+        <p:cNvPr id="1" name="">
+          <a:extLst>
+            <a:ext uri="{FF2B5EF4-FFF2-40B4-BE49-F238E27FC236}">
+              <a16:creationId xmlns:a16="http://schemas.microsoft.com/office/drawing/2014/main" id="{75556F0D-233C-5263-573B-720000B938F2}"/>
+            </a:ext>
+          </a:extLst>
+        </p:cNvPr>
+        <p:cNvGrpSpPr/>
+        <p:nvPr/>
+      </p:nvGrpSpPr>
+      <p:grpSpPr>
+        <a:xfrm>
+          <a:off x="0" y="0"/>
+          <a:ext cx="0" cy="0"/>
+          <a:chOff x="0" y="0"/>
+          <a:chExt cx="0" cy="0"/>
+        </a:xfrm>
+      </p:grpSpPr>
+      <p:sp>
+        <p:nvSpPr>
+          <p:cNvPr id="3" name="TextBox 2">
+            <a:extLst>
+              <a:ext uri="{FF2B5EF4-FFF2-40B4-BE49-F238E27FC236}">
+                <a16:creationId xmlns:a16="http://schemas.microsoft.com/office/drawing/2014/main" id="{C8387234-0FA2-5D1E-6E33-34031968FCDD}"/>
+              </a:ext>
+            </a:extLst>
+          </p:cNvPr>
+          <p:cNvSpPr txBox="1"/>
+          <p:nvPr/>
+        </p:nvSpPr>
+        <p:spPr>
+          <a:xfrm>
+            <a:off x="217714" y="255046"/>
+            <a:ext cx="11756571" cy="355354"/>
+          </a:xfrm>
+          <a:prstGeom prst="rect">
+            <a:avLst/>
+          </a:prstGeom>
+          <a:noFill/>
+        </p:spPr>
+        <p:txBody>
+          <a:bodyPr wrap="square">
+            <a:spAutoFit/>
+          </a:bodyPr>
+          <a:lstStyle/>
+          <a:p>
+            <a:pPr>
+              <a:lnSpc>
+                <a:spcPct val="150000"/>
+              </a:lnSpc>
+              <a:buNone/>
+            </a:pPr>
+            <a:r>
+              <a:rPr kumimoji="0" lang="en-US" altLang="en-US" sz="1300" b="0" i="0" u="none" strike="noStrike" cap="none" normalizeH="0" baseline="0">
+                <a:ln>
+                  <a:noFill/>
+                </a:ln>
+                <a:solidFill>
+                  <a:schemeClr val="tx1"/>
+                </a:solidFill>
+                <a:effectLst/>
+                <a:latin typeface="Arial" panose="020B0604020202020204" pitchFamily="34" charset="0"/>
+              </a:rPr>
+              <a:t>.</a:t>
+            </a:r>
+          </a:p>
+        </p:txBody>
+      </p:sp>
+      <p:pic>
+        <p:nvPicPr>
+          <p:cNvPr id="4" name="Picture 3">
+            <a:extLst>
+              <a:ext uri="{FF2B5EF4-FFF2-40B4-BE49-F238E27FC236}">
+                <a16:creationId xmlns:a16="http://schemas.microsoft.com/office/drawing/2014/main" id="{7B72CA30-20AE-5794-ECFA-1551435CFAF4}"/>
+              </a:ext>
+            </a:extLst>
+          </p:cNvPr>
+          <p:cNvPicPr>
+            <a:picLocks noChangeAspect="1"/>
+          </p:cNvPicPr>
+          <p:nvPr/>
+        </p:nvPicPr>
+        <p:blipFill>
+          <a:blip r:embed="rId2"/>
+          <a:stretch>
+            <a:fillRect/>
+          </a:stretch>
+        </p:blipFill>
+        <p:spPr>
+          <a:xfrm>
+            <a:off x="7070721" y="0"/>
+            <a:ext cx="5121279" cy="6858000"/>
+          </a:xfrm>
+          <a:prstGeom prst="rect">
+            <a:avLst/>
+          </a:prstGeom>
+        </p:spPr>
+      </p:pic>
+    </p:spTree>
+    <p:extLst>
+      <p:ext uri="{BB962C8B-B14F-4D97-AF65-F5344CB8AC3E}">
+        <p14:creationId xmlns:p14="http://schemas.microsoft.com/office/powerpoint/2010/main" val="2878432807"/>
+      </p:ext>
+    </p:extLst>
+  </p:cSld>
+  <p:clrMapOvr>
+    <a:masterClrMapping/>
+  </p:clrMapOvr>
+</p:sld>
+</file>
+
+<file path=ppt/slides/slide5.xml><?xml version="1.0" encoding="utf-8"?>
+<p:sld xmlns:a="http://schemas.openxmlformats.org/drawingml/2006/main" xmlns:r="http://schemas.openxmlformats.org/officeDocument/2006/relationships" xmlns:p="http://schemas.openxmlformats.org/presentationml/2006/main">
+  <p:cSld>
+    <p:spTree>
+      <p:nvGrpSpPr>
+        <p:cNvPr id="1" name="">
+          <a:extLst>
+            <a:ext uri="{FF2B5EF4-FFF2-40B4-BE49-F238E27FC236}">
+              <a16:creationId xmlns:a16="http://schemas.microsoft.com/office/drawing/2014/main" id="{3F716DC7-5B3C-F913-2598-4D85A1DC9844}"/>
+            </a:ext>
+          </a:extLst>
+        </p:cNvPr>
+        <p:cNvGrpSpPr/>
+        <p:nvPr/>
+      </p:nvGrpSpPr>
+      <p:grpSpPr>
+        <a:xfrm>
+          <a:off x="0" y="0"/>
+          <a:ext cx="0" cy="0"/>
+          <a:chOff x="0" y="0"/>
+          <a:chExt cx="0" cy="0"/>
+        </a:xfrm>
+      </p:grpSpPr>
+      <p:sp>
+        <p:nvSpPr>
+          <p:cNvPr id="3" name="TextBox 2">
+            <a:extLst>
+              <a:ext uri="{FF2B5EF4-FFF2-40B4-BE49-F238E27FC236}">
+                <a16:creationId xmlns:a16="http://schemas.microsoft.com/office/drawing/2014/main" id="{E0FDE323-FE81-092B-3B7F-F65ADE52EF14}"/>
+              </a:ext>
+            </a:extLst>
+          </p:cNvPr>
+          <p:cNvSpPr txBox="1"/>
+          <p:nvPr/>
+        </p:nvSpPr>
+        <p:spPr>
+          <a:xfrm>
+            <a:off x="217714" y="255046"/>
+            <a:ext cx="11756571" cy="355354"/>
+          </a:xfrm>
+          <a:prstGeom prst="rect">
+            <a:avLst/>
+          </a:prstGeom>
+          <a:noFill/>
+        </p:spPr>
+        <p:txBody>
+          <a:bodyPr wrap="square">
+            <a:spAutoFit/>
+          </a:bodyPr>
+          <a:lstStyle/>
+          <a:p>
+            <a:pPr>
+              <a:lnSpc>
+                <a:spcPct val="150000"/>
+              </a:lnSpc>
+              <a:buNone/>
+            </a:pPr>
+            <a:r>
+              <a:rPr kumimoji="0" lang="en-US" altLang="en-US" sz="1300" b="0" i="0" u="none" strike="noStrike" cap="none" normalizeH="0" baseline="0">
+                <a:ln>
+                  <a:noFill/>
+                </a:ln>
+                <a:solidFill>
+                  <a:schemeClr val="tx1"/>
+                </a:solidFill>
+                <a:effectLst/>
+                <a:latin typeface="Arial" panose="020B0604020202020204" pitchFamily="34" charset="0"/>
+              </a:rPr>
+              <a:t>.</a:t>
+            </a:r>
+          </a:p>
+        </p:txBody>
+      </p:sp>
+      <p:pic>
+        <p:nvPicPr>
+          <p:cNvPr id="4" name="Picture 3">
+            <a:extLst>
+              <a:ext uri="{FF2B5EF4-FFF2-40B4-BE49-F238E27FC236}">
+                <a16:creationId xmlns:a16="http://schemas.microsoft.com/office/drawing/2014/main" id="{E20B06FB-3399-F3A5-C22E-EE80DCB3D6D9}"/>
+              </a:ext>
+            </a:extLst>
+          </p:cNvPr>
+          <p:cNvPicPr>
+            <a:picLocks noChangeAspect="1"/>
+          </p:cNvPicPr>
+          <p:nvPr/>
+        </p:nvPicPr>
+        <p:blipFill>
+          <a:blip r:embed="rId2"/>
+          <a:stretch>
+            <a:fillRect/>
+          </a:stretch>
+        </p:blipFill>
+        <p:spPr>
+          <a:xfrm>
+            <a:off x="-9236" y="2783406"/>
+            <a:ext cx="12192000" cy="4074594"/>
+          </a:xfrm>
+          <a:prstGeom prst="rect">
+            <a:avLst/>
+          </a:prstGeom>
+        </p:spPr>
+      </p:pic>
+    </p:spTree>
+    <p:extLst>
+      <p:ext uri="{BB962C8B-B14F-4D97-AF65-F5344CB8AC3E}">
+        <p14:creationId xmlns:p14="http://schemas.microsoft.com/office/powerpoint/2010/main" val="3285000024"/>
+      </p:ext>
+    </p:extLst>
+  </p:cSld>
+  <p:clrMapOvr>
+    <a:masterClrMapping/>
+  </p:clrMapOvr>
+</p:sld>
+</file>
+
+<file path=ppt/slides/slide6.xml><?xml version="1.0" encoding="utf-8"?>
+<p:sld xmlns:a="http://schemas.openxmlformats.org/drawingml/2006/main" xmlns:r="http://schemas.openxmlformats.org/officeDocument/2006/relationships" xmlns:p="http://schemas.openxmlformats.org/presentationml/2006/main">
+  <p:cSld>
+    <p:spTree>
+      <p:nvGrpSpPr>
+        <p:cNvPr id="1" name="">
+          <a:extLst>
+            <a:ext uri="{FF2B5EF4-FFF2-40B4-BE49-F238E27FC236}">
+              <a16:creationId xmlns:a16="http://schemas.microsoft.com/office/drawing/2014/main" id="{64174925-6C44-9A01-A8E4-9EB7D60B1E7D}"/>
+            </a:ext>
+          </a:extLst>
+        </p:cNvPr>
+        <p:cNvGrpSpPr/>
+        <p:nvPr/>
+      </p:nvGrpSpPr>
+      <p:grpSpPr>
+        <a:xfrm>
+          <a:off x="0" y="0"/>
+          <a:ext cx="0" cy="0"/>
+          <a:chOff x="0" y="0"/>
+          <a:chExt cx="0" cy="0"/>
+        </a:xfrm>
+      </p:grpSpPr>
+      <p:sp>
+        <p:nvSpPr>
+          <p:cNvPr id="3" name="TextBox 2">
+            <a:extLst>
+              <a:ext uri="{FF2B5EF4-FFF2-40B4-BE49-F238E27FC236}">
+                <a16:creationId xmlns:a16="http://schemas.microsoft.com/office/drawing/2014/main" id="{2310DEAB-738D-FB99-12F6-09A2429EA9FE}"/>
+              </a:ext>
+            </a:extLst>
+          </p:cNvPr>
+          <p:cNvSpPr txBox="1"/>
+          <p:nvPr/>
+        </p:nvSpPr>
+        <p:spPr>
+          <a:xfrm>
+            <a:off x="217714" y="255046"/>
+            <a:ext cx="11756571" cy="355354"/>
+          </a:xfrm>
+          <a:prstGeom prst="rect">
+            <a:avLst/>
+          </a:prstGeom>
+          <a:noFill/>
+        </p:spPr>
+        <p:txBody>
+          <a:bodyPr wrap="square">
+            <a:spAutoFit/>
+          </a:bodyPr>
+          <a:lstStyle/>
+          <a:p>
+            <a:pPr>
+              <a:lnSpc>
+                <a:spcPct val="150000"/>
+              </a:lnSpc>
+              <a:buNone/>
+            </a:pPr>
+            <a:r>
+              <a:rPr kumimoji="0" lang="en-US" altLang="en-US" sz="1300" b="0" i="0" u="none" strike="noStrike" cap="none" normalizeH="0" baseline="0">
+                <a:ln>
+                  <a:noFill/>
+                </a:ln>
+                <a:solidFill>
+                  <a:schemeClr val="tx1"/>
+                </a:solidFill>
+                <a:effectLst/>
+                <a:latin typeface="Arial" panose="020B0604020202020204" pitchFamily="34" charset="0"/>
+              </a:rPr>
+              <a:t>.</a:t>
+            </a:r>
+          </a:p>
+        </p:txBody>
+      </p:sp>
+      <p:pic>
+        <p:nvPicPr>
+          <p:cNvPr id="4" name="Picture 3">
+            <a:extLst>
+              <a:ext uri="{FF2B5EF4-FFF2-40B4-BE49-F238E27FC236}">
+                <a16:creationId xmlns:a16="http://schemas.microsoft.com/office/drawing/2014/main" id="{0DD5A057-CCD5-6547-97EC-535DE8239E82}"/>
+              </a:ext>
+            </a:extLst>
+          </p:cNvPr>
+          <p:cNvPicPr>
+            <a:picLocks noChangeAspect="1"/>
+          </p:cNvPicPr>
+          <p:nvPr/>
+        </p:nvPicPr>
+        <p:blipFill>
+          <a:blip r:embed="rId2"/>
+          <a:stretch>
+            <a:fillRect/>
+          </a:stretch>
+        </p:blipFill>
+        <p:spPr>
+          <a:xfrm>
+            <a:off x="1632914" y="1728550"/>
+            <a:ext cx="8926171" cy="3400900"/>
+          </a:xfrm>
+          <a:prstGeom prst="rect">
+            <a:avLst/>
+          </a:prstGeom>
+          <a:ln>
+            <a:noFill/>
+          </a:ln>
+          <a:effectLst>
+            <a:outerShdw blurRad="292100" dist="139700" dir="2700000" algn="tl" rotWithShape="0">
+              <a:srgbClr val="333333">
+                <a:alpha val="65000"/>
+              </a:srgbClr>
+            </a:outerShdw>
+          </a:effectLst>
+        </p:spPr>
+      </p:pic>
+    </p:spTree>
+    <p:extLst>
+      <p:ext uri="{BB962C8B-B14F-4D97-AF65-F5344CB8AC3E}">
+        <p14:creationId xmlns:p14="http://schemas.microsoft.com/office/powerpoint/2010/main" val="590041318"/>
+      </p:ext>
+    </p:extLst>
+  </p:cSld>
+  <p:clrMapOvr>
+    <a:masterClrMapping/>
+  </p:clrMapOvr>
+</p:sld>
+</file>
+
+<file path=ppt/slides/slide7.xml><?xml version="1.0" encoding="utf-8"?>
+<p:sld xmlns:a="http://schemas.openxmlformats.org/drawingml/2006/main" xmlns:r="http://schemas.openxmlformats.org/officeDocument/2006/relationships" xmlns:p="http://schemas.openxmlformats.org/presentationml/2006/main">
+  <p:cSld>
+    <p:spTree>
+      <p:nvGrpSpPr>
+        <p:cNvPr id="1" name="">
+          <a:extLst>
+            <a:ext uri="{FF2B5EF4-FFF2-40B4-BE49-F238E27FC236}">
+              <a16:creationId xmlns:a16="http://schemas.microsoft.com/office/drawing/2014/main" id="{F7FC2E01-248D-51AC-9F4A-3585D843CC41}"/>
+            </a:ext>
+          </a:extLst>
+        </p:cNvPr>
+        <p:cNvGrpSpPr/>
+        <p:nvPr/>
+      </p:nvGrpSpPr>
+      <p:grpSpPr>
+        <a:xfrm>
+          <a:off x="0" y="0"/>
+          <a:ext cx="0" cy="0"/>
+          <a:chOff x="0" y="0"/>
+          <a:chExt cx="0" cy="0"/>
+        </a:xfrm>
+      </p:grpSpPr>
+      <p:sp>
+        <p:nvSpPr>
+          <p:cNvPr id="3" name="TextBox 2">
+            <a:extLst>
+              <a:ext uri="{FF2B5EF4-FFF2-40B4-BE49-F238E27FC236}">
+                <a16:creationId xmlns:a16="http://schemas.microsoft.com/office/drawing/2014/main" id="{627717CC-9EAD-EDCD-1391-D03EAE62B25A}"/>
+              </a:ext>
+            </a:extLst>
+          </p:cNvPr>
+          <p:cNvSpPr txBox="1"/>
+          <p:nvPr/>
+        </p:nvSpPr>
+        <p:spPr>
+          <a:xfrm>
+            <a:off x="217714" y="255046"/>
+            <a:ext cx="11756571" cy="355354"/>
+          </a:xfrm>
+          <a:prstGeom prst="rect">
+            <a:avLst/>
+          </a:prstGeom>
+          <a:noFill/>
+        </p:spPr>
+        <p:txBody>
+          <a:bodyPr wrap="square">
+            <a:spAutoFit/>
+          </a:bodyPr>
+          <a:lstStyle/>
+          <a:p>
+            <a:pPr>
+              <a:lnSpc>
+                <a:spcPct val="150000"/>
+              </a:lnSpc>
+              <a:buNone/>
+            </a:pPr>
+            <a:r>
+              <a:rPr kumimoji="0" lang="en-US" altLang="en-US" sz="1300" b="0" i="0" u="none" strike="noStrike" cap="none" normalizeH="0" baseline="0">
+                <a:ln>
+                  <a:noFill/>
+                </a:ln>
+                <a:solidFill>
+                  <a:schemeClr val="tx1"/>
+                </a:solidFill>
+                <a:effectLst/>
+                <a:latin typeface="Arial" panose="020B0604020202020204" pitchFamily="34" charset="0"/>
+              </a:rPr>
+              <a:t>.</a:t>
+            </a:r>
+          </a:p>
+        </p:txBody>
+      </p:sp>
+    </p:spTree>
+    <p:extLst>
+      <p:ext uri="{BB962C8B-B14F-4D97-AF65-F5344CB8AC3E}">
+        <p14:creationId xmlns:p14="http://schemas.microsoft.com/office/powerpoint/2010/main" val="2038506422"/>
+      </p:ext>
+    </p:extLst>
+  </p:cSld>
+  <p:clrMapOvr>
+    <a:masterClrMapping/>
+  </p:clrMapOvr>
+</p:sld>
+</file>
+
+<file path=ppt/slides/slide8.xml><?xml version="1.0" encoding="utf-8"?>
+<p:sld xmlns:a="http://schemas.openxmlformats.org/drawingml/2006/main" xmlns:r="http://schemas.openxmlformats.org/officeDocument/2006/relationships" xmlns:p="http://schemas.openxmlformats.org/presentationml/2006/main">
+  <p:cSld>
+    <p:spTree>
+      <p:nvGrpSpPr>
+        <p:cNvPr id="1" name="">
+          <a:extLst>
+            <a:ext uri="{FF2B5EF4-FFF2-40B4-BE49-F238E27FC236}">
+              <a16:creationId xmlns:a16="http://schemas.microsoft.com/office/drawing/2014/main" id="{1ED8BF57-4784-2EB9-7EF4-ABF3D27FBE2B}"/>
+            </a:ext>
+          </a:extLst>
+        </p:cNvPr>
+        <p:cNvGrpSpPr/>
+        <p:nvPr/>
+      </p:nvGrpSpPr>
+      <p:grpSpPr>
+        <a:xfrm>
+          <a:off x="0" y="0"/>
+          <a:ext cx="0" cy="0"/>
+          <a:chOff x="0" y="0"/>
+          <a:chExt cx="0" cy="0"/>
+        </a:xfrm>
+      </p:grpSpPr>
+      <p:sp>
+        <p:nvSpPr>
+          <p:cNvPr id="3" name="TextBox 2">
+            <a:extLst>
+              <a:ext uri="{FF2B5EF4-FFF2-40B4-BE49-F238E27FC236}">
+                <a16:creationId xmlns:a16="http://schemas.microsoft.com/office/drawing/2014/main" id="{5737582A-737A-50B0-618B-E9AE9C9A0C03}"/>
+              </a:ext>
+            </a:extLst>
+          </p:cNvPr>
+          <p:cNvSpPr txBox="1"/>
+          <p:nvPr/>
+        </p:nvSpPr>
+        <p:spPr>
+          <a:xfrm>
+            <a:off x="217714" y="255046"/>
+            <a:ext cx="11756571" cy="355354"/>
+          </a:xfrm>
+          <a:prstGeom prst="rect">
+            <a:avLst/>
+          </a:prstGeom>
+          <a:noFill/>
+        </p:spPr>
+        <p:txBody>
+          <a:bodyPr wrap="square">
+            <a:spAutoFit/>
+          </a:bodyPr>
+          <a:lstStyle/>
+          <a:p>
+            <a:pPr>
+              <a:lnSpc>
+                <a:spcPct val="150000"/>
+              </a:lnSpc>
+              <a:buNone/>
+            </a:pPr>
+            <a:r>
+              <a:rPr kumimoji="0" lang="en-US" altLang="en-US" sz="1300" b="0" i="0" u="none" strike="noStrike" cap="none" normalizeH="0" baseline="0">
+                <a:ln>
+                  <a:noFill/>
+                </a:ln>
+                <a:solidFill>
+                  <a:schemeClr val="tx1"/>
+                </a:solidFill>
+                <a:effectLst/>
+                <a:latin typeface="Arial" panose="020B0604020202020204" pitchFamily="34" charset="0"/>
+              </a:rPr>
+              <a:t>.</a:t>
+            </a:r>
+          </a:p>
+        </p:txBody>
+      </p:sp>
+    </p:spTree>
+    <p:extLst>
+      <p:ext uri="{BB962C8B-B14F-4D97-AF65-F5344CB8AC3E}">
+        <p14:creationId xmlns:p14="http://schemas.microsoft.com/office/powerpoint/2010/main" val="297416395"/>
+      </p:ext>
+    </p:extLst>
+  </p:cSld>
+  <p:clrMapOvr>
+    <a:masterClrMapping/>
+  </p:clrMapOvr>
+</p:sld>
+</file>
+
+<file path=ppt/slides/slide9.xml><?xml version="1.0" encoding="utf-8"?>
 <p:sld xmlns:a="http://schemas.openxmlformats.org/drawingml/2006/main" xmlns:r="http://schemas.openxmlformats.org/officeDocument/2006/relationships" xmlns:p="http://schemas.openxmlformats.org/presentationml/2006/main">
   <p:cSld>
     <p:spTree>

</xml_diff>